<commit_message>
feat: professional institutional UI/UX polish across all pillars
</commit_message>
<xml_diff>
--- a/IntelliCredit_Hackathon_Presentation.pptx
+++ b/IntelliCredit_Hackathon_Presentation.pptx
@@ -8971,13 +8971,13 @@
               <a:rPr lang="en-US" sz="1000" dirty="0">
                 <a:hlinkClick r:id="rId4"/>
               </a:rPr>
-              <a:t>https://github.com/Parshav2304</a:t>
+              <a:t>https://</a:t>
             </a:r>
             <a:r>
               <a:rPr lang="en-US" sz="1000" dirty="0" smtClean="0">
                 <a:hlinkClick r:id="rId4"/>
               </a:rPr>
-              <a:t>/</a:t>
+              <a:t>github.com/Parshav2304/IntelliCredit</a:t>
             </a:r>
             <a:endParaRPr lang="en-US" sz="1000" dirty="0" smtClean="0"/>
           </a:p>

</xml_diff>